<commit_message>
Brake Fluid %: fix ranker header that still read BRAKE FLUSH %
Co-Authored-By: Claude Opus 5.5 <noreply@anthropic.com>
Claude-Session: https://claude.ai/code/session_01Xa4nFVxuQGXmHARGph9WhS
</commit_message>
<xml_diff>
--- a/day2-deck/decks/Opcode Benchmarks - House Style.pptx
+++ b/day2-deck/decks/Opcode Benchmarks - House Style.pptx
@@ -5724,7 +5724,7 @@
           <a:p>
             <a:r>
               <a:rPr lang="en-US" dirty="0"/>
-              <a:t>Source: Qlik - Closed Repair Orders. Customer pay, Jan-Sep by close month. Same-store, INEOS excluded (opened 2026). GMC Prescott body shop labor excluded. BRAKE FLUSH % = brake fluid service ROs ÷ customer-pay ROs on the op-code report basis. YTD from YTD totals, not the mean of months.</a:t>
+              <a:t>Source: Qlik - Closed Repair Orders. Customer pay, Jan-Sep by close month. Same-store, INEOS excluded (opened 2026). GMC Prescott body shop labor excluded. BRAKE FLUID % = brake fluid service ROs ÷ customer-pay ROs on the op-code report basis. YTD from YTD totals, not the mean of months.</a:t>
             </a:r>
             <a:endParaRPr lang="en-US" dirty="0"/>
           </a:p>
@@ -19127,7 +19127,7 @@
                 <a:ea typeface="Inter" pitchFamily="34" charset="-122"/>
                 <a:cs typeface="Inter" pitchFamily="34" charset="-120"/>
               </a:rPr>
-              <a:t>BRAKE FLUSH %</a:t>
+              <a:t>BRAKE FLUID %</a:t>
             </a:r>
             <a:endParaRPr lang="en-US" sz="1500" dirty="0"/>
           </a:p>

</xml_diff>

<commit_message>
Fuel/balance movers: manufacturer no-call stores off the lists; moving-now sparkline dashed Jan-Mar average (review)
Co-Authored-By: Claude Opus 5.5 <noreply@anthropic.com>
Claude-Session: https://claude.ai/code/session_01Xa4nFVxuQGXmHARGph9WhS
</commit_message>
<xml_diff>
--- a/day2-deck/decks/Opcode Benchmarks - House Style.pptx
+++ b/day2-deck/decks/Opcode Benchmarks - House Style.pptx
@@ -8383,7 +8383,7 @@
           <a:p>
             <a:r>
               <a:rPr lang="en-US" dirty="0"/>
-              <a:t>Takeaway with the store call-outs (off the slide): Ask Subaru St George, Lincoln and LR LV what changed. Ask Subaru LV, CDJR Post Falls and Toyota Spokane what got in the way. Ask Mazda, Hyundai St George and Honda Spokane what they started this year.Source: Qlik - Closed Repair Orders. Customer pay, Jan-Sep by close month. Same-store, INEOS excluded (opened 2026). GMC Prescott body shop labor excluded. Top and bottom five stores by change in Fuel Service %, Jan-Sep 2026 vs 2025, in points. Moving now: Jul-Sep 2026 vs Jan-Mar 2026, each store against itself; the group moved −0.3 pts on the same basis, so part of every store's change is seasonal. Green bar at the right of a row: the store is on both the top five vs last year and the top five moving now. Blue bar: a turnaround, on the bottom five vs last year and the top five moving now.Conversation starter: each top store says one thing they started doing; each bottom store says what got in the way and what they would try. The room trades ideas. Moving now: ask the top three what they started this year.</a:t>
+              <a:t>Takeaway with the store call-outs (off the slide): Ask Subaru St George, Lincoln and LR LV what changed. Ask Subaru LV, CDJR Post Falls and Toyota Spokane what got in the way. Ask Mazda, Hyundai St George and Honda Spokane what they started this year.Source: Qlik - Closed Repair Orders. Customer pay, Jan-Sep by close month. Same-store, INEOS excluded (opened 2026). GMC Prescott body shop labor excluded. Top and bottom five stores by change in Fuel Service %, Jan-Sep 2026 vs 2025, in points. Not ranked: Volvo, Audi Henderson, VW Henderson, Audi Reno (the manufacturer doesn't call for fuel service); ranks out of 29. Moving now: Jul-Sep 2026 vs Jan-Mar 2026, each store against itself; the group moved −0.3 pts on the same basis, so part of every store's change is seasonal. Green bar at the right of a row: the store is on both the top five vs last year and the top five moving now. Blue bar: a turnaround, on the bottom five vs last year and the top five moving now.Conversation starter: each top store says one thing they started doing; each bottom store says what got in the way and what they would try. The room trades ideas. Moving now: ask the top three what they started this year.</a:t>
             </a:r>
             <a:endParaRPr lang="en-US" dirty="0"/>
           </a:p>
@@ -8977,7 +8977,7 @@
           <a:p>
             <a:r>
               <a:rPr lang="en-US" dirty="0"/>
-              <a:t>Takeaway with the store call-outs (off the slide): Ask Subaru Prescott, LR LV and Mazda what changed. Ask Subaru St George, Nissan and Kia LV what got in the way. Ask Mazda, Hyundai Prescott and Honda Spokane what they started this year.Source: Qlik - Closed Repair Orders. Customer pay, Jan-Sep by close month. Same-store, INEOS excluded (opened 2026). GMC Prescott body shop labor excluded. Top and bottom five stores by change in Balance %, Jan-Sep 2026 vs 2025, in points. Moving now: Jul-Sep 2026 vs Jan-Mar 2026, each store against itself; the group moved +0.1 pts on the same basis, so part of every store's change is seasonal. Green bar at the right of a row: the store is on both the top five vs last year and the top five moving now. Blue bar: a turnaround, on the bottom five vs last year and the top five moving now.Conversation starter: each top store says one thing they started doing; each bottom store says what got in the way and what they would try. The room trades ideas. Moving now: ask the top three what they started this year.</a:t>
+              <a:t>Takeaway with the store call-outs (off the slide): Ask Subaru Prescott, LR LV and Mazda what changed. Ask Subaru St George, Nissan and Kia LV what got in the way. Ask Mazda, Hyundai Prescott and Honda Spokane what they started this year.Source: Qlik - Closed Repair Orders. Customer pay, Jan-Sep by close month. Same-store, INEOS excluded (opened 2026). GMC Prescott body shop labor excluded. Top and bottom five stores by change in Balance %, Jan-Sep 2026 vs 2025, in points. Not ranked: Audi Henderson, Audi Reno (the manufacturer doesn't call for balance); ranks out of 31. Moving now: Jul-Sep 2026 vs Jan-Mar 2026, each store against itself; the group moved +0.1 pts on the same basis, so part of every store's change is seasonal. Green bar at the right of a row: the store is on both the top five vs last year and the top five moving now. Blue bar: a turnaround, on the bottom five vs last year and the top five moving now.Conversation starter: each top store says one thing they started doing; each bottom store says what got in the way and what they would try. The room trades ideas. Moving now: ask the top three what they started this year.</a:t>
             </a:r>
             <a:endParaRPr lang="en-US" dirty="0"/>
           </a:p>
@@ -19819,7 +19819,7 @@
                 <a:ea typeface="Inter" pitchFamily="34" charset="-122"/>
                 <a:cs typeface="Inter" pitchFamily="34" charset="-120"/>
               </a:rPr>
-              <a:t>33</a:t>
+              <a:t>29</a:t>
             </a:r>
             <a:endParaRPr lang="en-US" sz="1500" dirty="0"/>
           </a:p>
@@ -19976,7 +19976,7 @@
                 <a:ea typeface="Inter" pitchFamily="34" charset="-122"/>
                 <a:cs typeface="Inter" pitchFamily="34" charset="-120"/>
               </a:rPr>
-              <a:t>32</a:t>
+              <a:t>28</a:t>
             </a:r>
             <a:endParaRPr lang="en-US" sz="1500" dirty="0"/>
           </a:p>
@@ -20153,7 +20153,7 @@
                 <a:ea typeface="Inter" pitchFamily="34" charset="-122"/>
                 <a:cs typeface="Inter" pitchFamily="34" charset="-120"/>
               </a:rPr>
-              <a:t>31</a:t>
+              <a:t>27</a:t>
             </a:r>
             <a:endParaRPr lang="en-US" sz="1500" dirty="0"/>
           </a:p>
@@ -20310,7 +20310,7 @@
                 <a:ea typeface="Inter" pitchFamily="34" charset="-122"/>
                 <a:cs typeface="Inter" pitchFamily="34" charset="-120"/>
               </a:rPr>
-              <a:t>30</a:t>
+              <a:t>26</a:t>
             </a:r>
             <a:endParaRPr lang="en-US" sz="1500" dirty="0"/>
           </a:p>
@@ -20352,7 +20352,7 @@
                 <a:ea typeface="Inter" pitchFamily="34" charset="-122"/>
                 <a:cs typeface="Inter" pitchFamily="34" charset="-120"/>
               </a:rPr>
-              <a:t>Volvo</a:t>
+              <a:t>Toyota Flagstaff</a:t>
             </a:r>
             <a:endParaRPr lang="en-US" sz="1400" dirty="0"/>
           </a:p>
@@ -20372,7 +20372,7 @@
                 <a:ea typeface="Inter" pitchFamily="34" charset="-122"/>
                 <a:cs typeface="Inter" pitchFamily="34" charset="-120"/>
               </a:rPr>
-              <a:t>0.0%  →  </a:t>
+              <a:t>1.6%  →  </a:t>
             </a:r>
             <a:pPr indent="0" marL="0">
               <a:spcAft>
@@ -20389,7 +20389,7 @@
                 <a:ea typeface="Inter" pitchFamily="34" charset="-122"/>
                 <a:cs typeface="Inter" pitchFamily="34" charset="-120"/>
               </a:rPr>
-              <a:t>0.0%</a:t>
+              <a:t>1.6%</a:t>
             </a:r>
             <a:endParaRPr lang="en-US" sz="1400" dirty="0"/>
           </a:p>
@@ -20487,7 +20487,7 @@
                 <a:ea typeface="Inter" pitchFamily="34" charset="-122"/>
                 <a:cs typeface="Inter" pitchFamily="34" charset="-120"/>
               </a:rPr>
-              <a:t>29</a:t>
+              <a:t>25</a:t>
             </a:r>
             <a:endParaRPr lang="en-US" sz="1500" dirty="0"/>
           </a:p>
@@ -20529,7 +20529,7 @@
                 <a:ea typeface="Inter" pitchFamily="34" charset="-122"/>
                 <a:cs typeface="Inter" pitchFamily="34" charset="-120"/>
               </a:rPr>
-              <a:t>Audi Henderson</a:t>
+              <a:t>Toyota Henderson</a:t>
             </a:r>
             <a:endParaRPr lang="en-US" sz="1400" dirty="0"/>
           </a:p>
@@ -20549,7 +20549,7 @@
                 <a:ea typeface="Inter" pitchFamily="34" charset="-122"/>
                 <a:cs typeface="Inter" pitchFamily="34" charset="-120"/>
               </a:rPr>
-              <a:t>0.0%  →  </a:t>
+              <a:t>6.0%  →  </a:t>
             </a:r>
             <a:pPr indent="0" marL="0">
               <a:spcAft>
@@ -20566,7 +20566,7 @@
                 <a:ea typeface="Inter" pitchFamily="34" charset="-122"/>
                 <a:cs typeface="Inter" pitchFamily="34" charset="-120"/>
               </a:rPr>
-              <a:t>0.0%</a:t>
+              <a:t>6.0%</a:t>
             </a:r>
             <a:endParaRPr lang="en-US" sz="1400" dirty="0"/>
           </a:p>
@@ -37757,7 +37757,7 @@
                 <a:ea typeface="Inter" pitchFamily="34" charset="-122"/>
                 <a:cs typeface="Inter" pitchFamily="34" charset="-120"/>
               </a:rPr>
-              <a:t>33</a:t>
+              <a:t>31</a:t>
             </a:r>
             <a:endParaRPr lang="en-US" sz="1500" dirty="0"/>
           </a:p>
@@ -37914,7 +37914,7 @@
                 <a:ea typeface="Inter" pitchFamily="34" charset="-122"/>
                 <a:cs typeface="Inter" pitchFamily="34" charset="-120"/>
               </a:rPr>
-              <a:t>32</a:t>
+              <a:t>30</a:t>
             </a:r>
             <a:endParaRPr lang="en-US" sz="1500" dirty="0"/>
           </a:p>
@@ -38091,7 +38091,7 @@
                 <a:ea typeface="Inter" pitchFamily="34" charset="-122"/>
                 <a:cs typeface="Inter" pitchFamily="34" charset="-120"/>
               </a:rPr>
-              <a:t>31</a:t>
+              <a:t>29</a:t>
             </a:r>
             <a:endParaRPr lang="en-US" sz="1500" dirty="0"/>
           </a:p>
@@ -38248,7 +38248,7 @@
                 <a:ea typeface="Inter" pitchFamily="34" charset="-122"/>
                 <a:cs typeface="Inter" pitchFamily="34" charset="-120"/>
               </a:rPr>
-              <a:t>30</a:t>
+              <a:t>28</a:t>
             </a:r>
             <a:endParaRPr lang="en-US" sz="1500" dirty="0"/>
           </a:p>
@@ -38425,7 +38425,7 @@
                 <a:ea typeface="Inter" pitchFamily="34" charset="-122"/>
                 <a:cs typeface="Inter" pitchFamily="34" charset="-120"/>
               </a:rPr>
-              <a:t>29</a:t>
+              <a:t>27</a:t>
             </a:r>
             <a:endParaRPr lang="en-US" sz="1500" dirty="0"/>
           </a:p>

</xml_diff>